<commit_message>
Update Cliar Figure Issue #322
</commit_message>
<xml_diff>
--- a/app/www/CLIAR_template.pptx
+++ b/app/www/CLIAR_template.pptx
@@ -527,7 +527,7 @@
           <a:p>
             <a:fld id="{9EFFC45B-4969-4982-B259-08F17AE2E29E}" type="datetimeFigureOut">
               <a:rPr lang="en-US" smtClean="0"/>
-              <a:t>9/27/2024</a:t>
+              <a:t>12/10/24</a:t>
             </a:fld>
             <a:endParaRPr lang="en-US"/>
           </a:p>
@@ -3798,10 +3798,10 @@
       </p:sp>
       <p:pic>
         <p:nvPicPr>
-          <p:cNvPr id="9" name="Picture 8" descr="A diagram of different types of information&#10;&#10;Description automatically generated with medium confidence">
+          <p:cNvPr id="6" name="Picture 5" descr="A diagram of a diagram with text and icons&#10;&#10;Description automatically generated">
             <a:extLst>
               <a:ext uri="{FF2B5EF4-FFF2-40B4-BE49-F238E27FC236}">
-                <a16:creationId xmlns:a16="http://schemas.microsoft.com/office/drawing/2014/main" id="{40FE912B-E1ED-2F03-6BA4-CC80E1F56643}"/>
+                <a16:creationId xmlns:a16="http://schemas.microsoft.com/office/drawing/2014/main" id="{623C72CC-25A6-9740-810F-E3893305EF29}"/>
               </a:ext>
             </a:extLst>
           </p:cNvPr>
@@ -3824,8 +3824,8 @@
         </p:blipFill>
         <p:spPr>
           <a:xfrm>
-            <a:off x="6481904" y="916475"/>
-            <a:ext cx="5535396" cy="4666640"/>
+            <a:off x="6096000" y="781050"/>
+            <a:ext cx="5943600" cy="4495800"/>
           </a:xfrm>
           <a:prstGeom prst="rect">
             <a:avLst/>
@@ -6478,6 +6478,15 @@
 </file>
 
 <file path=customXml/item1.xml><?xml version="1.0" encoding="utf-8"?>
+<?mso-contentType ?>
+<FormTemplates xmlns="http://schemas.microsoft.com/sharepoint/v3/contenttype/forms">
+  <Display>DocumentLibraryForm</Display>
+  <Edit>DocumentLibraryForm</Edit>
+  <New>DocumentLibraryForm</New>
+</FormTemplates>
+</file>
+
+<file path=customXml/item2.xml><?xml version="1.0" encoding="utf-8"?>
 <ct:contentTypeSchema xmlns:ct="http://schemas.microsoft.com/office/2006/metadata/contentType" xmlns:ma="http://schemas.microsoft.com/office/2006/metadata/properties/metaAttributes" ct:_="" ma:_="" ma:contentTypeName="Document" ma:contentTypeID="0x01010098E9BA56E76D2447B6B33114ABBEA9D5" ma:contentTypeVersion="17" ma:contentTypeDescription="Create a new document." ma:contentTypeScope="" ma:versionID="eab5cebe44a9e109ecf62201a47214c6">
   <xsd:schema xmlns:xsd="http://www.w3.org/2001/XMLSchema" xmlns:xs="http://www.w3.org/2001/XMLSchema" xmlns:p="http://schemas.microsoft.com/office/2006/metadata/properties" xmlns:ns3="f1e5155a-4de1-4edf-b0c6-53134e0e5e81" xmlns:ns4="5b55b796-daa0-475c-b335-bbbb10b30c8e" targetNamespace="http://schemas.microsoft.com/office/2006/metadata/properties" ma:root="true" ma:fieldsID="dc852987dc368e0378459c8db44b5057" ns3:_="" ns4:_="">
     <xsd:import namespace="f1e5155a-4de1-4edf-b0c6-53134e0e5e81"/>
@@ -6724,15 +6733,6 @@
 </ct:contentTypeSchema>
 </file>
 
-<file path=customXml/item2.xml><?xml version="1.0" encoding="utf-8"?>
-<?mso-contentType ?>
-<FormTemplates xmlns="http://schemas.microsoft.com/sharepoint/v3/contenttype/forms">
-  <Display>DocumentLibraryForm</Display>
-  <Edit>DocumentLibraryForm</Edit>
-  <New>DocumentLibraryForm</New>
-</FormTemplates>
-</file>
-
 <file path=customXml/item3.xml><?xml version="1.0" encoding="utf-8"?>
 <p:properties xmlns:p="http://schemas.microsoft.com/office/2006/metadata/properties" xmlns:xsi="http://www.w3.org/2001/XMLSchema-instance" xmlns:pc="http://schemas.microsoft.com/office/infopath/2007/PartnerControls">
   <documentManagement>
@@ -6742,6 +6742,14 @@
 </file>
 
 <file path=customXml/itemProps1.xml><?xml version="1.0" encoding="utf-8"?>
+<ds:datastoreItem xmlns:ds="http://schemas.openxmlformats.org/officeDocument/2006/customXml" ds:itemID="{37500ECD-F1A1-4CA3-A5DC-2E37CCD17AB4}">
+  <ds:schemaRefs>
+    <ds:schemaRef ds:uri="http://schemas.microsoft.com/sharepoint/v3/contenttype/forms"/>
+  </ds:schemaRefs>
+</ds:datastoreItem>
+</file>
+
+<file path=customXml/itemProps2.xml><?xml version="1.0" encoding="utf-8"?>
 <ds:datastoreItem xmlns:ds="http://schemas.openxmlformats.org/officeDocument/2006/customXml" ds:itemID="{AD731547-222C-4B6E-862E-4C4E35A78C01}">
   <ds:schemaRefs>
     <ds:schemaRef ds:uri="5b55b796-daa0-475c-b335-bbbb10b30c8e"/>
@@ -6756,14 +6764,6 @@
     <ds:schemaRef ds:uri="http://schemas.microsoft.com/office/infopath/2007/PartnerControls"/>
     <ds:schemaRef ds:uri="http://schemas.openxmlformats.org/package/2006/metadata/core-properties"/>
     <ds:schemaRef ds:uri="http://www.w3.org/2001/XMLSchema"/>
-  </ds:schemaRefs>
-</ds:datastoreItem>
-</file>
-
-<file path=customXml/itemProps2.xml><?xml version="1.0" encoding="utf-8"?>
-<ds:datastoreItem xmlns:ds="http://schemas.openxmlformats.org/officeDocument/2006/customXml" ds:itemID="{37500ECD-F1A1-4CA3-A5DC-2E37CCD17AB4}">
-  <ds:schemaRefs>
-    <ds:schemaRef ds:uri="http://schemas.microsoft.com/sharepoint/v3/contenttype/forms"/>
   </ds:schemaRefs>
 </ds:datastoreItem>
 </file>

</xml_diff>